<commit_message>
Update final SourcePilot demo deck
</commit_message>
<xml_diff>
--- a/demo/SourcePilot-deck.pptx
+++ b/demo/SourcePilot-deck.pptx
@@ -2,23 +2,23 @@
 <file path=ppt/presentation.xml><?xml version="1.0" encoding="utf-8"?>
 <p:presentation xmlns:p="http://schemas.openxmlformats.org/presentationml/2006/main">
   <p:sldMasterIdLst>
-    <p:sldMasterId xmlns:r="http://schemas.openxmlformats.org/officeDocument/2006/relationships" id="2147483648" r:id="R65fd60b8ae45496f"/>
+    <p:sldMasterId xmlns:r="http://schemas.openxmlformats.org/officeDocument/2006/relationships" id="2147483648" r:id="R88d7610acbf048ae"/>
   </p:sldMasterIdLst>
   <p:notesMasterIdLst>
-    <p:notesMasterId xmlns:r="http://schemas.openxmlformats.org/officeDocument/2006/relationships" r:id="R3525cc6d96084cb2"/>
+    <p:notesMasterId xmlns:r="http://schemas.openxmlformats.org/officeDocument/2006/relationships" r:id="R6ec91edb9ec6428b"/>
   </p:notesMasterIdLst>
   <p:sldIdLst>
-    <p:sldId xmlns:r="http://schemas.openxmlformats.org/officeDocument/2006/relationships" id="256" r:id="R498d22edaed741c7"/>
-    <p:sldId xmlns:r="http://schemas.openxmlformats.org/officeDocument/2006/relationships" id="257" r:id="Red41bf6db73d4b38"/>
-    <p:sldId xmlns:r="http://schemas.openxmlformats.org/officeDocument/2006/relationships" id="258" r:id="Rf2d49fff5f044e14"/>
-    <p:sldId xmlns:r="http://schemas.openxmlformats.org/officeDocument/2006/relationships" id="259" r:id="R1df9adc2fc934254"/>
-    <p:sldId xmlns:r="http://schemas.openxmlformats.org/officeDocument/2006/relationships" id="260" r:id="Rae91a4df9f0d4505"/>
-    <p:sldId xmlns:r="http://schemas.openxmlformats.org/officeDocument/2006/relationships" id="261" r:id="R4d713423cd1f47b3"/>
-    <p:sldId xmlns:r="http://schemas.openxmlformats.org/officeDocument/2006/relationships" id="262" r:id="R632eac0bf80d49ae"/>
-    <p:sldId xmlns:r="http://schemas.openxmlformats.org/officeDocument/2006/relationships" id="263" r:id="R1986808a5238442d"/>
-    <p:sldId xmlns:r="http://schemas.openxmlformats.org/officeDocument/2006/relationships" id="264" r:id="R9366d5e99cf24f20"/>
-    <p:sldId xmlns:r="http://schemas.openxmlformats.org/officeDocument/2006/relationships" id="265" r:id="R99253bdddf6a45ec"/>
-    <p:sldId xmlns:r="http://schemas.openxmlformats.org/officeDocument/2006/relationships" id="266" r:id="R6dba780e1abf47fd"/>
+    <p:sldId xmlns:r="http://schemas.openxmlformats.org/officeDocument/2006/relationships" id="256" r:id="Rb94c8daea53449c1"/>
+    <p:sldId xmlns:r="http://schemas.openxmlformats.org/officeDocument/2006/relationships" id="257" r:id="R6588cf0ff0f0434c"/>
+    <p:sldId xmlns:r="http://schemas.openxmlformats.org/officeDocument/2006/relationships" id="258" r:id="Rb71bd29561ad419c"/>
+    <p:sldId xmlns:r="http://schemas.openxmlformats.org/officeDocument/2006/relationships" id="259" r:id="R5ae669b2b8cb4b1d"/>
+    <p:sldId xmlns:r="http://schemas.openxmlformats.org/officeDocument/2006/relationships" id="260" r:id="R61e1a8d17d064316"/>
+    <p:sldId xmlns:r="http://schemas.openxmlformats.org/officeDocument/2006/relationships" id="261" r:id="R272f1065dd984794"/>
+    <p:sldId xmlns:r="http://schemas.openxmlformats.org/officeDocument/2006/relationships" id="262" r:id="R611dfb72fa264c98"/>
+    <p:sldId xmlns:r="http://schemas.openxmlformats.org/officeDocument/2006/relationships" id="263" r:id="R6855181609d14cb7"/>
+    <p:sldId xmlns:r="http://schemas.openxmlformats.org/officeDocument/2006/relationships" id="264" r:id="R994fa614c7c14208"/>
+    <p:sldId xmlns:r="http://schemas.openxmlformats.org/officeDocument/2006/relationships" id="265" r:id="R2c65244f595142c3"/>
+    <p:sldId xmlns:r="http://schemas.openxmlformats.org/officeDocument/2006/relationships" id="266" r:id="R54d7f3d1e4de4165"/>
   </p:sldIdLst>
   <p:sldSz cx="12191695" cy="6858000"/>
   <p:notesSz cx="6858000" cy="9144000"/>
@@ -825,7 +825,12 @@
           <a:lstStyle xmlns:a="http://schemas.openxmlformats.org/drawingml/2006/main"/>
           <a:p xmlns:a="http://schemas.openxmlformats.org/drawingml/2006/main">
             <a:r>
-              <a:t>Hanzhou is recommended because it clears the signed sourcing terms. The cheapest quote is rejected because shipping, delivery, specification, and deposit terms fail policy checks.</a:t>
+              <a:t>Click the slide title to open the live supplier comparison website. Live URL: https://rain-agentic-sourcepilot.vercel.app/compare</a:t>
+            </a:r>
+          </a:p>
+          <a:p xmlns:a="http://schemas.openxmlformats.org/drawingml/2006/main">
+            <a:r>
+              <a:t>Keep the original screenshot on screen as a stable fallback during the demo.</a:t>
             </a:r>
           </a:p>
           <a:p xmlns:a="http://schemas.openxmlformats.org/drawingml/2006/main">
@@ -840,7 +845,7 @@
           </a:p>
           <a:p xmlns:a="http://schemas.openxmlformats.org/drawingml/2006/main">
             <a:r>
-              <a:t>- /Users/yingzhou/Desktop/Screenshot 2026-08-09 at 12.43.49 AM.png (user-provided screenshot, captured 2026-08-09)</a:t>
+              <a:t>- https://rain-agentic-sourcepilot.vercel.app/compare (live deployed route, accessed 2026-08-09)</a:t>
             </a:r>
           </a:p>
           <a:p xmlns:a="http://schemas.openxmlformats.org/drawingml/2006/main">
@@ -915,7 +920,12 @@
           <a:lstStyle xmlns:a="http://schemas.openxmlformats.org/drawingml/2006/main"/>
           <a:p xmlns:a="http://schemas.openxmlformats.org/drawingml/2006/main">
             <a:r>
-              <a:t>Point to the $200 autonomous threshold and the pending founder approval. Do not submit the payment form during the recording.</a:t>
+              <a:t>Click the slide title to open the live owner-approval website. Live URL: https://rain-agentic-sourcepilot.vercel.app/approve</a:t>
+            </a:r>
+          </a:p>
+          <a:p xmlns:a="http://schemas.openxmlformats.org/drawingml/2006/main">
+            <a:r>
+              <a:t>Keep the original screenshot on screen as a stable fallback during the demo.</a:t>
             </a:r>
           </a:p>
           <a:p xmlns:a="http://schemas.openxmlformats.org/drawingml/2006/main">
@@ -930,7 +940,7 @@
           </a:p>
           <a:p xmlns:a="http://schemas.openxmlformats.org/drawingml/2006/main">
             <a:r>
-              <a:t>- /Users/yingzhou/Desktop/Screenshot 2026-08-09 at 12.44.08 AM.png (user-provided screenshot, captured 2026-08-09)</a:t>
+              <a:t>- https://rain-agentic-sourcepilot.vercel.app/approve (live deployed route, accessed 2026-08-09)</a:t>
             </a:r>
           </a:p>
           <a:p xmlns:a="http://schemas.openxmlformats.org/drawingml/2006/main">
@@ -1275,7 +1285,7 @@
           <a:lstStyle xmlns:a="http://schemas.openxmlformats.org/drawingml/2006/main"/>
           <a:p xmlns:a="http://schemas.openxmlformats.org/drawingml/2006/main">
             <a:r>
-              <a:t>Show only the successful result: authenticated true, GET /issuing/transactions, HTTP 200, and transaction count zero. Never display the API key or authentication header.</a:t>
+              <a:t>Show only the successful result: the active Rain sandbox card, last four digits, and expiry. Never display the API key, session secret, PAN, CVC, or authentication header.</a:t>
             </a:r>
           </a:p>
           <a:p xmlns:a="http://schemas.openxmlformats.org/drawingml/2006/main">
@@ -1290,7 +1300,7 @@
           </a:p>
           <a:p xmlns:a="http://schemas.openxmlformats.org/drawingml/2006/main">
             <a:r>
-              <a:t>- /Users/yingzhou/Desktop/Screenshot 2026-08-09 at 12.41.52 AM.png (user-provided screenshot, captured 2026-08-09)</a:t>
+              <a:t>- /Users/yingzhou/Desktop/Screenshot 2026-08-09 at 9.48.13 AM.png (user-provided screenshot, captured 2026-08-09)</a:t>
             </a:r>
           </a:p>
           <a:p xmlns:a="http://schemas.openxmlformats.org/drawingml/2006/main">
@@ -4322,17 +4332,17 @@
   </p:cSld>
   <p:clrMap bg1="lt1" tx1="dk1" bg2="lt2" tx2="dk2" accent1="accent1" accent2="accent2" accent3="accent3" accent4="accent4" accent5="accent5" accent6="accent6" hlink="hlink" folHlink="folHlink"/>
   <p:sldLayoutIdLst>
-    <p:sldLayoutId xmlns:r="http://schemas.openxmlformats.org/officeDocument/2006/relationships" id="2147483649" r:id="R523c7ad39ca54bfc"/>
-    <p:sldLayoutId xmlns:r="http://schemas.openxmlformats.org/officeDocument/2006/relationships" id="2147483650" r:id="Rdd25e791339044e4"/>
-    <p:sldLayoutId xmlns:r="http://schemas.openxmlformats.org/officeDocument/2006/relationships" id="2147483651" r:id="Rcf7370e419734aa1"/>
-    <p:sldLayoutId xmlns:r="http://schemas.openxmlformats.org/officeDocument/2006/relationships" id="2147483652" r:id="Rfbab329f27164dc3"/>
-    <p:sldLayoutId xmlns:r="http://schemas.openxmlformats.org/officeDocument/2006/relationships" id="2147483653" r:id="Rca86dd79ba8f416b"/>
-    <p:sldLayoutId xmlns:r="http://schemas.openxmlformats.org/officeDocument/2006/relationships" id="2147483654" r:id="Re99299f549f64fec"/>
-    <p:sldLayoutId xmlns:r="http://schemas.openxmlformats.org/officeDocument/2006/relationships" id="2147483655" r:id="R72d3c892e1cc4a83"/>
-    <p:sldLayoutId xmlns:r="http://schemas.openxmlformats.org/officeDocument/2006/relationships" id="2147483656" r:id="R56089b75f359498a"/>
-    <p:sldLayoutId xmlns:r="http://schemas.openxmlformats.org/officeDocument/2006/relationships" id="2147483657" r:id="Re93b53d467f54f6b"/>
-    <p:sldLayoutId xmlns:r="http://schemas.openxmlformats.org/officeDocument/2006/relationships" id="2147483658" r:id="R2eb914bfb1004b07"/>
-    <p:sldLayoutId xmlns:r="http://schemas.openxmlformats.org/officeDocument/2006/relationships" id="2147483659" r:id="R812637bf1ab44a01"/>
+    <p:sldLayoutId xmlns:r="http://schemas.openxmlformats.org/officeDocument/2006/relationships" id="2147483649" r:id="Rae9e010849e34524"/>
+    <p:sldLayoutId xmlns:r="http://schemas.openxmlformats.org/officeDocument/2006/relationships" id="2147483650" r:id="R0dad54761cc549b0"/>
+    <p:sldLayoutId xmlns:r="http://schemas.openxmlformats.org/officeDocument/2006/relationships" id="2147483651" r:id="R7b4be81054de479f"/>
+    <p:sldLayoutId xmlns:r="http://schemas.openxmlformats.org/officeDocument/2006/relationships" id="2147483652" r:id="Rc3e9dc211fe0409c"/>
+    <p:sldLayoutId xmlns:r="http://schemas.openxmlformats.org/officeDocument/2006/relationships" id="2147483653" r:id="R986dac4ae97747cc"/>
+    <p:sldLayoutId xmlns:r="http://schemas.openxmlformats.org/officeDocument/2006/relationships" id="2147483654" r:id="R826231ed94c84a41"/>
+    <p:sldLayoutId xmlns:r="http://schemas.openxmlformats.org/officeDocument/2006/relationships" id="2147483655" r:id="R610186be92d24bae"/>
+    <p:sldLayoutId xmlns:r="http://schemas.openxmlformats.org/officeDocument/2006/relationships" id="2147483656" r:id="R1b673f61b1a94c3f"/>
+    <p:sldLayoutId xmlns:r="http://schemas.openxmlformats.org/officeDocument/2006/relationships" id="2147483657" r:id="R23c7d4f7c94f4d4b"/>
+    <p:sldLayoutId xmlns:r="http://schemas.openxmlformats.org/officeDocument/2006/relationships" id="2147483658" r:id="R6813ba6b4c87418d"/>
+    <p:sldLayoutId xmlns:r="http://schemas.openxmlformats.org/officeDocument/2006/relationships" id="2147483659" r:id="R1d5796b4bb014aab"/>
   </p:sldLayoutIdLst>
   <p:txStyles>
     <p:titleStyle>
@@ -10974,6 +10984,7 @@
           <a:lstStyle xmlns:a="http://schemas.openxmlformats.org/drawingml/2006/main"/>
           <a:p xmlns:a="http://schemas.openxmlformats.org/drawingml/2006/main">
             <a:pPr algn="ctr">
+              <a:buNone/>
               <a:defRPr sz="900" b="1">
                 <a:solidFill>
                   <a:srgbClr val="10150E"/>
@@ -11034,6 +11045,7 @@
           <a:lstStyle xmlns:a="http://schemas.openxmlformats.org/drawingml/2006/main"/>
           <a:p xmlns:a="http://schemas.openxmlformats.org/drawingml/2006/main">
             <a:pPr>
+              <a:buNone/>
               <a:defRPr sz="2850" b="1">
                 <a:solidFill>
                   <a:srgbClr val="F2F5F8"/>
@@ -11094,6 +11106,7 @@
           <a:lstStyle xmlns:a="http://schemas.openxmlformats.org/drawingml/2006/main"/>
           <a:p xmlns:a="http://schemas.openxmlformats.org/drawingml/2006/main">
             <a:pPr>
+              <a:buNone/>
               <a:defRPr sz="1275">
                 <a:solidFill>
                   <a:srgbClr val="9BACBE"/>
@@ -11154,14 +11167,14 @@
       </p:sp>
       <p:pic>
         <p:nvPicPr>
-          <p:cNvPr id="12" name="evidence-image-1"/>
+          <p:cNvPr id="14" name="evidence-image-1"/>
           <p:cNvPicPr>
             <a:picLocks xmlns:a="http://schemas.openxmlformats.org/drawingml/2006/main" noChangeAspect="1"/>
           </p:cNvPicPr>
           <p:nvPr/>
         </p:nvPicPr>
         <p:blipFill>
-          <a:blip xmlns:r="http://schemas.openxmlformats.org/officeDocument/2006/relationships" xmlns:a="http://schemas.openxmlformats.org/drawingml/2006/main" r:embed="Rcb62da2299cb4402"/>
+          <a:blip xmlns:r="http://schemas.openxmlformats.org/officeDocument/2006/relationships" xmlns:a="http://schemas.openxmlformats.org/drawingml/2006/main" r:embed="R900a1e373b0e4dcb"/>
           <a:srcRect xmlns:a="http://schemas.openxmlformats.org/drawingml/2006/main" l="0" t="26919" r="0" b="26919"/>
           <a:stretch xmlns:a="http://schemas.openxmlformats.org/drawingml/2006/main">
             <a:fillRect l="0" t="0" r="0" b="0"/>
@@ -11273,6 +11286,7 @@
           <a:lstStyle xmlns:a="http://schemas.openxmlformats.org/drawingml/2006/main"/>
           <a:p xmlns:a="http://schemas.openxmlformats.org/drawingml/2006/main">
             <a:pPr algn="ctr">
+              <a:buNone/>
               <a:defRPr sz="900" b="1">
                 <a:solidFill>
                   <a:srgbClr val="10150E"/>
@@ -11333,6 +11347,7 @@
           <a:lstStyle xmlns:a="http://schemas.openxmlformats.org/drawingml/2006/main"/>
           <a:p xmlns:a="http://schemas.openxmlformats.org/drawingml/2006/main">
             <a:pPr>
+              <a:buNone/>
               <a:defRPr sz="2850" b="1">
                 <a:solidFill>
                   <a:srgbClr val="F2F5F8"/>
@@ -11393,6 +11408,7 @@
           <a:lstStyle xmlns:a="http://schemas.openxmlformats.org/drawingml/2006/main"/>
           <a:p xmlns:a="http://schemas.openxmlformats.org/drawingml/2006/main">
             <a:pPr>
+              <a:buNone/>
               <a:defRPr sz="1275">
                 <a:solidFill>
                   <a:srgbClr val="9BACBE"/>
@@ -11453,14 +11469,14 @@
       </p:sp>
       <p:pic>
         <p:nvPicPr>
-          <p:cNvPr id="12" name="evidence-image-2"/>
+          <p:cNvPr id="14" name="evidence-image-2"/>
           <p:cNvPicPr>
             <a:picLocks xmlns:a="http://schemas.openxmlformats.org/drawingml/2006/main" noChangeAspect="1"/>
           </p:cNvPicPr>
           <p:nvPr/>
         </p:nvPicPr>
         <p:blipFill>
-          <a:blip xmlns:r="http://schemas.openxmlformats.org/officeDocument/2006/relationships" xmlns:a="http://schemas.openxmlformats.org/drawingml/2006/main" r:embed="R35abe571a06f4456"/>
+          <a:blip xmlns:r="http://schemas.openxmlformats.org/officeDocument/2006/relationships" xmlns:a="http://schemas.openxmlformats.org/drawingml/2006/main" r:embed="R21b0a6c14efe4ae0"/>
           <a:srcRect xmlns:a="http://schemas.openxmlformats.org/drawingml/2006/main" l="0" t="28005" r="0" b="28005"/>
           <a:stretch xmlns:a="http://schemas.openxmlformats.org/drawingml/2006/main">
             <a:fillRect l="0" t="0" r="0" b="0"/>
@@ -11572,6 +11588,7 @@
           <a:lstStyle xmlns:a="http://schemas.openxmlformats.org/drawingml/2006/main"/>
           <a:p xmlns:a="http://schemas.openxmlformats.org/drawingml/2006/main">
             <a:pPr algn="ctr">
+              <a:buNone/>
               <a:defRPr sz="900" b="1">
                 <a:solidFill>
                   <a:srgbClr val="10150E"/>
@@ -11632,6 +11649,7 @@
           <a:lstStyle xmlns:a="http://schemas.openxmlformats.org/drawingml/2006/main"/>
           <a:p xmlns:a="http://schemas.openxmlformats.org/drawingml/2006/main">
             <a:pPr>
+              <a:buNone/>
               <a:defRPr sz="2850" b="1">
                 <a:solidFill>
                   <a:srgbClr val="F2F5F8"/>
@@ -11692,6 +11710,7 @@
           <a:lstStyle xmlns:a="http://schemas.openxmlformats.org/drawingml/2006/main"/>
           <a:p xmlns:a="http://schemas.openxmlformats.org/drawingml/2006/main">
             <a:pPr>
+              <a:buNone/>
               <a:defRPr sz="1275">
                 <a:solidFill>
                   <a:srgbClr val="9BACBE"/>
@@ -11752,14 +11771,14 @@
       </p:sp>
       <p:pic>
         <p:nvPicPr>
-          <p:cNvPr id="12" name="evidence-image-3"/>
+          <p:cNvPr id="14" name="evidence-image-3"/>
           <p:cNvPicPr>
             <a:picLocks xmlns:a="http://schemas.openxmlformats.org/drawingml/2006/main" noChangeAspect="1"/>
           </p:cNvPicPr>
           <p:nvPr/>
         </p:nvPicPr>
         <p:blipFill>
-          <a:blip xmlns:r="http://schemas.openxmlformats.org/officeDocument/2006/relationships" xmlns:a="http://schemas.openxmlformats.org/drawingml/2006/main" r:embed="Ra976cc3bee18490e"/>
+          <a:blip xmlns:r="http://schemas.openxmlformats.org/officeDocument/2006/relationships" xmlns:a="http://schemas.openxmlformats.org/drawingml/2006/main" r:embed="R229b62561a2a4da0"/>
           <a:stretch xmlns:a="http://schemas.openxmlformats.org/drawingml/2006/main"/>
         </p:blipFill>
         <p:spPr>
@@ -11868,6 +11887,7 @@
           <a:lstStyle xmlns:a="http://schemas.openxmlformats.org/drawingml/2006/main"/>
           <a:p xmlns:a="http://schemas.openxmlformats.org/drawingml/2006/main">
             <a:pPr algn="ctr">
+              <a:buNone/>
               <a:defRPr sz="900" b="1">
                 <a:solidFill>
                   <a:srgbClr val="10150E"/>
@@ -11928,6 +11948,7 @@
           <a:lstStyle xmlns:a="http://schemas.openxmlformats.org/drawingml/2006/main"/>
           <a:p xmlns:a="http://schemas.openxmlformats.org/drawingml/2006/main">
             <a:pPr>
+              <a:buNone/>
               <a:defRPr sz="2850" b="1">
                 <a:solidFill>
                   <a:srgbClr val="F2F5F8"/>
@@ -11988,6 +12009,7 @@
           <a:lstStyle xmlns:a="http://schemas.openxmlformats.org/drawingml/2006/main"/>
           <a:p xmlns:a="http://schemas.openxmlformats.org/drawingml/2006/main">
             <a:pPr>
+              <a:buNone/>
               <a:defRPr sz="1275">
                 <a:solidFill>
                   <a:srgbClr val="9BACBE"/>
@@ -12048,14 +12070,14 @@
       </p:sp>
       <p:pic>
         <p:nvPicPr>
-          <p:cNvPr id="12" name="evidence-image-4"/>
+          <p:cNvPr id="14" name="evidence-image-4"/>
           <p:cNvPicPr>
             <a:picLocks xmlns:a="http://schemas.openxmlformats.org/drawingml/2006/main" noChangeAspect="1"/>
           </p:cNvPicPr>
           <p:nvPr/>
         </p:nvPicPr>
         <p:blipFill>
-          <a:blip xmlns:r="http://schemas.openxmlformats.org/officeDocument/2006/relationships" xmlns:a="http://schemas.openxmlformats.org/drawingml/2006/main" r:embed="R67b4c2c26f3d45d2"/>
+          <a:blip xmlns:r="http://schemas.openxmlformats.org/officeDocument/2006/relationships" xmlns:a="http://schemas.openxmlformats.org/drawingml/2006/main" r:embed="Rf2fe90eb5edf4733"/>
           <a:srcRect xmlns:a="http://schemas.openxmlformats.org/drawingml/2006/main" l="0" t="25712" r="0" b="25712"/>
           <a:stretch xmlns:a="http://schemas.openxmlformats.org/drawingml/2006/main">
             <a:fillRect l="0" t="0" r="0" b="0"/>
@@ -12167,6 +12189,7 @@
           <a:lstStyle xmlns:a="http://schemas.openxmlformats.org/drawingml/2006/main"/>
           <a:p xmlns:a="http://schemas.openxmlformats.org/drawingml/2006/main">
             <a:pPr algn="ctr">
+              <a:buNone/>
               <a:defRPr sz="900" b="1">
                 <a:solidFill>
                   <a:srgbClr val="10150E"/>
@@ -12227,6 +12250,7 @@
           <a:lstStyle xmlns:a="http://schemas.openxmlformats.org/drawingml/2006/main"/>
           <a:p xmlns:a="http://schemas.openxmlformats.org/drawingml/2006/main">
             <a:pPr>
+              <a:buNone/>
               <a:defRPr sz="2850" b="1">
                 <a:solidFill>
                   <a:srgbClr val="F2F5F8"/>
@@ -12287,6 +12311,7 @@
           <a:lstStyle xmlns:a="http://schemas.openxmlformats.org/drawingml/2006/main"/>
           <a:p xmlns:a="http://schemas.openxmlformats.org/drawingml/2006/main">
             <a:pPr>
+              <a:buNone/>
               <a:defRPr sz="1275">
                 <a:solidFill>
                   <a:srgbClr val="9BACBE"/>
@@ -12347,14 +12372,14 @@
       </p:sp>
       <p:pic>
         <p:nvPicPr>
-          <p:cNvPr id="12" name="evidence-image-5"/>
+          <p:cNvPr id="14" name="evidence-image-5"/>
           <p:cNvPicPr>
             <a:picLocks xmlns:a="http://schemas.openxmlformats.org/drawingml/2006/main" noChangeAspect="1"/>
           </p:cNvPicPr>
           <p:nvPr/>
         </p:nvPicPr>
         <p:blipFill>
-          <a:blip xmlns:r="http://schemas.openxmlformats.org/officeDocument/2006/relationships" xmlns:a="http://schemas.openxmlformats.org/drawingml/2006/main" r:embed="R4d4731e0bd4a4603"/>
+          <a:blip xmlns:r="http://schemas.openxmlformats.org/officeDocument/2006/relationships" xmlns:a="http://schemas.openxmlformats.org/drawingml/2006/main" r:embed="R55ff0457af044331"/>
           <a:srcRect xmlns:a="http://schemas.openxmlformats.org/drawingml/2006/main" l="0" t="25665" r="0" b="25665"/>
           <a:stretch xmlns:a="http://schemas.openxmlformats.org/drawingml/2006/main">
             <a:fillRect l="0" t="0" r="0" b="0"/>
@@ -12466,6 +12491,7 @@
           <a:lstStyle xmlns:a="http://schemas.openxmlformats.org/drawingml/2006/main"/>
           <a:p xmlns:a="http://schemas.openxmlformats.org/drawingml/2006/main">
             <a:pPr algn="ctr">
+              <a:buNone/>
               <a:defRPr sz="900" b="1">
                 <a:solidFill>
                   <a:srgbClr val="10150E"/>
@@ -12526,6 +12552,7 @@
           <a:lstStyle xmlns:a="http://schemas.openxmlformats.org/drawingml/2006/main"/>
           <a:p xmlns:a="http://schemas.openxmlformats.org/drawingml/2006/main">
             <a:pPr>
+              <a:buNone/>
               <a:defRPr sz="2850" b="1">
                 <a:solidFill>
                   <a:srgbClr val="F2F5F8"/>
@@ -12544,7 +12571,7 @@
                 <a:ea typeface="Arial"/>
                 <a:cs typeface="Arial"/>
               </a:rPr>
-              <a:t>Authenticated Rain connectivity</a:t>
+              <a:t>Live Rain scoped card</a:t>
             </a:r>
           </a:p>
         </p:txBody>
@@ -12586,6 +12613,7 @@
           <a:lstStyle xmlns:a="http://schemas.openxmlformats.org/drawingml/2006/main"/>
           <a:p xmlns:a="http://schemas.openxmlformats.org/drawingml/2006/main">
             <a:pPr>
+              <a:buNone/>
               <a:defRPr sz="1275">
                 <a:solidFill>
                   <a:srgbClr val="9BACBE"/>
@@ -12604,7 +12632,7 @@
                 <a:ea typeface="Arial"/>
                 <a:cs typeface="Arial"/>
               </a:rPr>
-              <a:t>A live read-only sandbox call returns HTTP 200; issuance and settlement remain outside this build.</a:t>
+              <a:t>A live authenticated API read returns an active sandbox card; payment execution remains mocked.</a:t>
             </a:r>
           </a:p>
         </p:txBody>
@@ -12646,25 +12674,24 @@
       </p:sp>
       <p:pic>
         <p:nvPicPr>
-          <p:cNvPr id="12" name="evidence-image-6"/>
+          <p:cNvPr id="14" name="evidence-image-6"/>
           <p:cNvPicPr>
             <a:picLocks xmlns:a="http://schemas.openxmlformats.org/drawingml/2006/main" noChangeAspect="1"/>
           </p:cNvPicPr>
           <p:nvPr/>
         </p:nvPicPr>
         <p:blipFill>
-          <a:blip xmlns:r="http://schemas.openxmlformats.org/officeDocument/2006/relationships" xmlns:a="http://schemas.openxmlformats.org/drawingml/2006/main" r:embed="R27a3e1ab2b61402a"/>
+          <a:blip xmlns:r="http://schemas.openxmlformats.org/officeDocument/2006/relationships" xmlns:a="http://schemas.openxmlformats.org/drawingml/2006/main" r:embed="R2651fabe378a41d7"/>
+          <a:srcRect xmlns:a="http://schemas.openxmlformats.org/drawingml/2006/main" l="3000" t="50000" r="3000" b="0"/>
           <a:stretch xmlns:a="http://schemas.openxmlformats.org/drawingml/2006/main"/>
         </p:blipFill>
         <p:spPr>
-          <a:xfrm xmlns:a="http://schemas.openxmlformats.org/drawingml/2006/main">
+          <a:xfrm xmlns:a="http://schemas.openxmlformats.org/drawingml/2006/main" flipH="0" flipV="0">
             <a:off x="781050" y="2478369"/>
             <a:ext cx="10629900" cy="2929961"/>
           </a:xfrm>
           <a:prstGeom xmlns:a="http://schemas.openxmlformats.org/drawingml/2006/main" prst="roundRect">
-            <a:avLst>
-              <a:gd name="adj" fmla="val 2155"/>
-            </a:avLst>
+            <a:avLst/>
           </a:prstGeom>
         </p:spPr>
       </p:pic>

</xml_diff>